<commit_message>
fix: update poverty dashboard preview URL
</commit_message>
<xml_diff>
--- a/outputs/Muhammad_Ali_Akbar_Al-Qahri_Portfolio_Minimal.pptx
+++ b/outputs/Muhammad_Ali_Akbar_Al-Qahri_Portfolio_Minimal.pptx
@@ -2,23 +2,23 @@
 <file path=ppt/presentation.xml><?xml version="1.0" encoding="utf-8"?>
 <p:presentation xmlns:p="http://schemas.openxmlformats.org/presentationml/2006/main">
   <p:sldMasterIdLst>
-    <p:sldMasterId xmlns:r="http://schemas.openxmlformats.org/officeDocument/2006/relationships" id="2147483648" r:id="Rdcc13abbc4254258"/>
+    <p:sldMasterId xmlns:r="http://schemas.openxmlformats.org/officeDocument/2006/relationships" id="2147483648" r:id="Re93534e79ea74483"/>
   </p:sldMasterIdLst>
   <p:notesMasterIdLst>
-    <p:notesMasterId xmlns:r="http://schemas.openxmlformats.org/officeDocument/2006/relationships" r:id="R6619fad3fce84f83"/>
+    <p:notesMasterId xmlns:r="http://schemas.openxmlformats.org/officeDocument/2006/relationships" r:id="Rb524e3fcaf254a75"/>
   </p:notesMasterIdLst>
   <p:sldIdLst>
-    <p:sldId xmlns:r="http://schemas.openxmlformats.org/officeDocument/2006/relationships" id="256" r:id="R347feb2bf53d453c"/>
-    <p:sldId xmlns:r="http://schemas.openxmlformats.org/officeDocument/2006/relationships" id="257" r:id="R7ea1ab817bc3453f"/>
-    <p:sldId xmlns:r="http://schemas.openxmlformats.org/officeDocument/2006/relationships" id="258" r:id="R925fcf9e2ba7419d"/>
-    <p:sldId xmlns:r="http://schemas.openxmlformats.org/officeDocument/2006/relationships" id="259" r:id="R0f2f2faacc484070"/>
-    <p:sldId xmlns:r="http://schemas.openxmlformats.org/officeDocument/2006/relationships" id="260" r:id="Rab1ce1976bab4fcd"/>
-    <p:sldId xmlns:r="http://schemas.openxmlformats.org/officeDocument/2006/relationships" id="261" r:id="R330645ab13114cad"/>
-    <p:sldId xmlns:r="http://schemas.openxmlformats.org/officeDocument/2006/relationships" id="262" r:id="Rd9e622a42d5049d3"/>
-    <p:sldId xmlns:r="http://schemas.openxmlformats.org/officeDocument/2006/relationships" id="263" r:id="Rba4526a53de747cd"/>
-    <p:sldId xmlns:r="http://schemas.openxmlformats.org/officeDocument/2006/relationships" id="264" r:id="Rdedb8c3895b043aa"/>
-    <p:sldId xmlns:r="http://schemas.openxmlformats.org/officeDocument/2006/relationships" id="265" r:id="R057db855ff6d4712"/>
-    <p:sldId xmlns:r="http://schemas.openxmlformats.org/officeDocument/2006/relationships" id="266" r:id="R4beb1c60706248ca"/>
+    <p:sldId xmlns:r="http://schemas.openxmlformats.org/officeDocument/2006/relationships" id="256" r:id="Rb1d3a0d99b6241db"/>
+    <p:sldId xmlns:r="http://schemas.openxmlformats.org/officeDocument/2006/relationships" id="257" r:id="R43b1576311f54b6e"/>
+    <p:sldId xmlns:r="http://schemas.openxmlformats.org/officeDocument/2006/relationships" id="258" r:id="R54da300d612a4345"/>
+    <p:sldId xmlns:r="http://schemas.openxmlformats.org/officeDocument/2006/relationships" id="259" r:id="R21ae3d4c48874739"/>
+    <p:sldId xmlns:r="http://schemas.openxmlformats.org/officeDocument/2006/relationships" id="260" r:id="Rbd67f0bb09ba4876"/>
+    <p:sldId xmlns:r="http://schemas.openxmlformats.org/officeDocument/2006/relationships" id="261" r:id="R50065fa66a8b47b1"/>
+    <p:sldId xmlns:r="http://schemas.openxmlformats.org/officeDocument/2006/relationships" id="262" r:id="Rebf699dbf24247dc"/>
+    <p:sldId xmlns:r="http://schemas.openxmlformats.org/officeDocument/2006/relationships" id="263" r:id="Rfac8d444573d4b4e"/>
+    <p:sldId xmlns:r="http://schemas.openxmlformats.org/officeDocument/2006/relationships" id="264" r:id="R0d0cce0fca29434b"/>
+    <p:sldId xmlns:r="http://schemas.openxmlformats.org/officeDocument/2006/relationships" id="265" r:id="R13b0462104c44051"/>
+    <p:sldId xmlns:r="http://schemas.openxmlformats.org/officeDocument/2006/relationships" id="266" r:id="Ra84ec83bfd944701"/>
   </p:sldIdLst>
   <p:sldSz cx="12192000" cy="6858000"/>
   <p:notesSz cx="6858000" cy="9144000"/>
@@ -1271,7 +1271,7 @@
   </p:cSld>
   <p:clrMap bg1="lt1" tx1="dk1" bg2="lt2" tx2="dk2" accent1="accent1" accent2="accent2" accent3="accent3" accent4="accent4" accent5="accent5" accent6="accent6" hlink="hlink" folHlink="folHlink"/>
   <p:sldLayoutIdLst>
-    <p:sldLayoutId xmlns:r="http://schemas.openxmlformats.org/officeDocument/2006/relationships" id="2147483649" r:id="R88b579e820b144e6"/>
+    <p:sldLayoutId xmlns:r="http://schemas.openxmlformats.org/officeDocument/2006/relationships" id="2147483649" r:id="R213fe65b11c043d6"/>
   </p:sldLayoutIdLst>
   <p:txStyles>
     <p:titleStyle>
@@ -2840,7 +2840,7 @@
                 <a:latin typeface="Aptos"/>
                 <a:ea typeface="Aptos"/>
                 <a:cs typeface="Aptos"/>
-                <a:hlinkClick xmlns:r="http://schemas.openxmlformats.org/officeDocument/2006/relationships" r:id="R8bfcc0f9918842fc"/>
+                <a:hlinkClick xmlns:r="http://schemas.openxmlformats.org/officeDocument/2006/relationships" r:id="Ra9b1d8b5ec014e07"/>
               </a:rPr>
               <a:t>OPEN THE COMPLETE WEB PORTFOLIO</a:t>
             </a:r>
@@ -2861,7 +2861,7 @@
                 <a:latin typeface="Consolas"/>
                 <a:ea typeface="Consolas"/>
                 <a:cs typeface="Consolas"/>
-                <a:hlinkClick xmlns:r="http://schemas.openxmlformats.org/officeDocument/2006/relationships" r:id="Rb4e843b81f124b38"/>
+                <a:hlinkClick xmlns:r="http://schemas.openxmlformats.org/officeDocument/2006/relationships" r:id="R663e65fe62114d46"/>
               </a:rPr>
               <a:t>akbaralqahri.github.io/portofolio</a:t>
             </a:r>
@@ -3084,7 +3084,7 @@
           <p:nvPr/>
         </p:nvPicPr>
         <p:blipFill>
-          <a:blip xmlns:r="http://schemas.openxmlformats.org/officeDocument/2006/relationships" xmlns:a="http://schemas.openxmlformats.org/drawingml/2006/main" r:embed="R68c521ce6abf4c57"/>
+          <a:blip xmlns:r="http://schemas.openxmlformats.org/officeDocument/2006/relationships" xmlns:a="http://schemas.openxmlformats.org/drawingml/2006/main" r:embed="R0dc3f6da909d4004"/>
           <a:srcRect xmlns:a="http://schemas.openxmlformats.org/drawingml/2006/main" l="0" t="28690" r="0" b="28690"/>
           <a:stretch xmlns:a="http://schemas.openxmlformats.org/drawingml/2006/main">
             <a:fillRect l="0" t="0" r="0" b="0"/>
@@ -5060,7 +5060,7 @@
                 <a:latin typeface="Aptos"/>
                 <a:ea typeface="Aptos"/>
                 <a:cs typeface="Aptos"/>
-                <a:hlinkClick xmlns:r="http://schemas.openxmlformats.org/officeDocument/2006/relationships" r:id="Rb028d1914756444b"/>
+                <a:hlinkClick xmlns:r="http://schemas.openxmlformats.org/officeDocument/2006/relationships" r:id="R0add6accbb5d4509"/>
               </a:rPr>
               <a:t>OPEN THE WEB PORTFOLIO</a:t>
             </a:r>
@@ -5081,7 +5081,7 @@
                 <a:latin typeface="Consolas"/>
                 <a:ea typeface="Consolas"/>
                 <a:cs typeface="Consolas"/>
-                <a:hlinkClick xmlns:r="http://schemas.openxmlformats.org/officeDocument/2006/relationships" r:id="R39cff000f5c241fa"/>
+                <a:hlinkClick xmlns:r="http://schemas.openxmlformats.org/officeDocument/2006/relationships" r:id="R9ae45b9719f74cbe"/>
               </a:rPr>
               <a:t>akbaralqahri.github.io/portofolio</a:t>
             </a:r>
@@ -5453,7 +5453,7 @@
                 <a:latin typeface="Aptos"/>
                 <a:ea typeface="Aptos"/>
                 <a:cs typeface="Aptos"/>
-                <a:hlinkClick xmlns:r="http://schemas.openxmlformats.org/officeDocument/2006/relationships" r:id="Rdea7bef2239645de"/>
+                <a:hlinkClick xmlns:r="http://schemas.openxmlformats.org/officeDocument/2006/relationships" r:id="Rd8bdb042aea64313"/>
               </a:rPr>
               <a:t>LINKEDIN · linkedin.com/in/akbaralqahri</a:t>
             </a:r>
@@ -5474,7 +5474,7 @@
                 <a:latin typeface="Aptos"/>
                 <a:ea typeface="Aptos"/>
                 <a:cs typeface="Aptos"/>
-                <a:hlinkClick xmlns:r="http://schemas.openxmlformats.org/officeDocument/2006/relationships" r:id="R84f968eb88df466a"/>
+                <a:hlinkClick xmlns:r="http://schemas.openxmlformats.org/officeDocument/2006/relationships" r:id="Rd1ec58b897aa409e"/>
               </a:rPr>
               <a:t>WEB PORTFOLIO · akbaralqahri.github.io/portofolio</a:t>
             </a:r>
@@ -5598,7 +5598,7 @@
           <p:nvPr/>
         </p:nvPicPr>
         <p:blipFill>
-          <a:blip xmlns:r="http://schemas.openxmlformats.org/officeDocument/2006/relationships" xmlns:a="http://schemas.openxmlformats.org/drawingml/2006/main" r:embed="Rb47c392991fa4ff0"/>
+          <a:blip xmlns:r="http://schemas.openxmlformats.org/officeDocument/2006/relationships" xmlns:a="http://schemas.openxmlformats.org/drawingml/2006/main" r:embed="R9c5a743ee8234a04"/>
           <a:srcRect xmlns:a="http://schemas.openxmlformats.org/drawingml/2006/main" l="0" t="5980" r="0" b="5980"/>
           <a:stretch xmlns:a="http://schemas.openxmlformats.org/drawingml/2006/main">
             <a:fillRect l="0" t="0" r="0" b="0"/>
@@ -10801,7 +10801,7 @@
                 <a:latin typeface="Aptos"/>
                 <a:ea typeface="Aptos"/>
                 <a:cs typeface="Aptos"/>
-                <a:hlinkClick xmlns:r="http://schemas.openxmlformats.org/officeDocument/2006/relationships" r:id="R280fbd81f0fe4a5e"/>
+                <a:hlinkClick xmlns:r="http://schemas.openxmlformats.org/officeDocument/2006/relationships" r:id="R148ad8a4c94e428b"/>
               </a:rPr>
               <a:t>OPEN PETA KEMISKINAN ↗</a:t>
             </a:r>
@@ -11024,7 +11024,7 @@
           <p:nvPr/>
         </p:nvPicPr>
         <p:blipFill>
-          <a:blip xmlns:r="http://schemas.openxmlformats.org/officeDocument/2006/relationships" xmlns:a="http://schemas.openxmlformats.org/drawingml/2006/main" r:embed="R7f059377d6ec42eb"/>
+          <a:blip xmlns:r="http://schemas.openxmlformats.org/officeDocument/2006/relationships" xmlns:a="http://schemas.openxmlformats.org/drawingml/2006/main" r:embed="R0be8cb4dfcc2494a"/>
           <a:srcRect xmlns:a="http://schemas.openxmlformats.org/drawingml/2006/main" l="0" t="16819" r="0" b="16819"/>
           <a:stretch xmlns:a="http://schemas.openxmlformats.org/drawingml/2006/main">
             <a:fillRect l="0" t="0" r="0" b="0"/>
@@ -11991,7 +11991,7 @@
           <p:nvPr/>
         </p:nvPicPr>
         <p:blipFill>
-          <a:blip xmlns:r="http://schemas.openxmlformats.org/officeDocument/2006/relationships" xmlns:a="http://schemas.openxmlformats.org/drawingml/2006/main" r:embed="R14b2ec6b512b4fb1"/>
+          <a:blip xmlns:r="http://schemas.openxmlformats.org/officeDocument/2006/relationships" xmlns:a="http://schemas.openxmlformats.org/drawingml/2006/main" r:embed="R574accc41120413a"/>
           <a:srcRect xmlns:a="http://schemas.openxmlformats.org/drawingml/2006/main" l="0" t="5719" r="0" b="5719"/>
           <a:stretch xmlns:a="http://schemas.openxmlformats.org/drawingml/2006/main">
             <a:fillRect l="0" t="0" r="0" b="0"/>
@@ -12018,7 +12018,7 @@
           <p:nvPr/>
         </p:nvPicPr>
         <p:blipFill>
-          <a:blip xmlns:r="http://schemas.openxmlformats.org/officeDocument/2006/relationships" xmlns:a="http://schemas.openxmlformats.org/drawingml/2006/main" r:embed="R64d078c2d1ef40d0"/>
+          <a:blip xmlns:r="http://schemas.openxmlformats.org/officeDocument/2006/relationships" xmlns:a="http://schemas.openxmlformats.org/drawingml/2006/main" r:embed="R04e76573a456484e"/>
           <a:srcRect xmlns:a="http://schemas.openxmlformats.org/drawingml/2006/main" l="0" t="5719" r="0" b="5719"/>
           <a:stretch xmlns:a="http://schemas.openxmlformats.org/drawingml/2006/main">
             <a:fillRect l="0" t="0" r="0" b="0"/>
@@ -13017,7 +13017,7 @@
           <p:nvPr/>
         </p:nvPicPr>
         <p:blipFill>
-          <a:blip xmlns:r="http://schemas.openxmlformats.org/officeDocument/2006/relationships" xmlns:a="http://schemas.openxmlformats.org/drawingml/2006/main" r:embed="Re25a45c6f5eb4f6d"/>
+          <a:blip xmlns:r="http://schemas.openxmlformats.org/officeDocument/2006/relationships" xmlns:a="http://schemas.openxmlformats.org/drawingml/2006/main" r:embed="R2c93be3a933f48e9"/>
           <a:stretch xmlns:a="http://schemas.openxmlformats.org/drawingml/2006/main"/>
         </p:blipFill>
         <p:spPr>
@@ -13041,7 +13041,7 @@
           <p:nvPr/>
         </p:nvPicPr>
         <p:blipFill>
-          <a:blip xmlns:r="http://schemas.openxmlformats.org/officeDocument/2006/relationships" xmlns:a="http://schemas.openxmlformats.org/drawingml/2006/main" r:embed="R71945bd7710b43ae"/>
+          <a:blip xmlns:r="http://schemas.openxmlformats.org/officeDocument/2006/relationships" xmlns:a="http://schemas.openxmlformats.org/drawingml/2006/main" r:embed="Re14cb9a244894f00"/>
           <a:stretch xmlns:a="http://schemas.openxmlformats.org/drawingml/2006/main"/>
         </p:blipFill>
         <p:spPr>
@@ -14083,7 +14083,7 @@
           <p:nvPr/>
         </p:nvPicPr>
         <p:blipFill>
-          <a:blip xmlns:r="http://schemas.openxmlformats.org/officeDocument/2006/relationships" xmlns:a="http://schemas.openxmlformats.org/drawingml/2006/main" r:embed="R178f17ccf9144646"/>
+          <a:blip xmlns:r="http://schemas.openxmlformats.org/officeDocument/2006/relationships" xmlns:a="http://schemas.openxmlformats.org/drawingml/2006/main" r:embed="R1855f3b6bd8e4b9c"/>
           <a:srcRect xmlns:a="http://schemas.openxmlformats.org/drawingml/2006/main" l="0" t="4261" r="0" b="4261"/>
           <a:stretch xmlns:a="http://schemas.openxmlformats.org/drawingml/2006/main">
             <a:fillRect l="0" t="0" r="0" b="0"/>
@@ -15069,7 +15069,7 @@
           <p:nvPr/>
         </p:nvPicPr>
         <p:blipFill>
-          <a:blip xmlns:r="http://schemas.openxmlformats.org/officeDocument/2006/relationships" xmlns:a="http://schemas.openxmlformats.org/drawingml/2006/main" r:embed="Rc567f63abe55439b"/>
+          <a:blip xmlns:r="http://schemas.openxmlformats.org/officeDocument/2006/relationships" xmlns:a="http://schemas.openxmlformats.org/drawingml/2006/main" r:embed="R639bc4c2ec604948"/>
           <a:srcRect xmlns:a="http://schemas.openxmlformats.org/drawingml/2006/main" l="10463" t="0" r="10463" b="0"/>
           <a:stretch xmlns:a="http://schemas.openxmlformats.org/drawingml/2006/main">
             <a:fillRect l="0" t="0" r="0" b="0"/>
@@ -15094,7 +15094,7 @@
           <p:nvPr/>
         </p:nvPicPr>
         <p:blipFill>
-          <a:blip xmlns:r="http://schemas.openxmlformats.org/officeDocument/2006/relationships" xmlns:a="http://schemas.openxmlformats.org/drawingml/2006/main" r:embed="Re60e27f00c1b49b3"/>
+          <a:blip xmlns:r="http://schemas.openxmlformats.org/officeDocument/2006/relationships" xmlns:a="http://schemas.openxmlformats.org/drawingml/2006/main" r:embed="Rcf3358ce9b20436b"/>
           <a:srcRect xmlns:a="http://schemas.openxmlformats.org/drawingml/2006/main" l="0" t="2825" r="0" b="2825"/>
           <a:stretch xmlns:a="http://schemas.openxmlformats.org/drawingml/2006/main">
             <a:fillRect l="0" t="0" r="0" b="0"/>
@@ -15121,7 +15121,7 @@
           <p:nvPr/>
         </p:nvPicPr>
         <p:blipFill>
-          <a:blip xmlns:r="http://schemas.openxmlformats.org/officeDocument/2006/relationships" xmlns:a="http://schemas.openxmlformats.org/drawingml/2006/main" r:embed="R59a1ba7627564bc9"/>
+          <a:blip xmlns:r="http://schemas.openxmlformats.org/officeDocument/2006/relationships" xmlns:a="http://schemas.openxmlformats.org/drawingml/2006/main" r:embed="R4a76b790473c4a2e"/>
           <a:srcRect xmlns:a="http://schemas.openxmlformats.org/drawingml/2006/main" l="0" t="5246" r="0" b="5246"/>
           <a:stretch xmlns:a="http://schemas.openxmlformats.org/drawingml/2006/main">
             <a:fillRect l="0" t="0" r="0" b="0"/>

</xml_diff>